<commit_message>
build(inbox/aan): regenerate derivatives after the content-correctness burndown
Re-rendered the tracked deliverables from the fixed sources:
- 163 figure PNGs re-rasterized from their SVG sources (+ provenance sidecars)
- 12 Vol VII/IX briefing decks (.pptx) regenerated from their specs
- 14 tracked Vol VII/IX book + governance .docx re-rendered via Pandoc
- distribution kit refreshed -> AAN_Federal_Series_Complete_2026-07-15_1503ET.zip

Source content was merged earlier in #1207-#1216; this syncs the binary
derivatives to it. Verified docx carry the fixes.

Co-Authored-By: Claude Fable 5 <noreply@anthropic.com>
</commit_message>
<xml_diff>
--- a/inbox/Application Aware Networking/Vol_IX_Book_01_FedAAN_Helpdesk_ITSM_Catalog.pptx
+++ b/inbox/Application Aware Networking/Vol_IX_Book_01_FedAAN_Helpdesk_ITSM_Catalog.pptx
@@ -10234,7 +10234,7 @@
                 <a:gridCol w="2743200"/>
                 <a:gridCol w="2743200"/>
               </a:tblGrid>
-              <a:tr h="685800">
+              <a:tr h="548640">
                 <a:tc>
                   <a:txBody>
                     <a:bodyPr/>
@@ -10302,7 +10302,7 @@
                   </a:tcPr>
                 </a:tc>
               </a:tr>
-              <a:tr h="685800">
+              <a:tr h="548640">
                 <a:tc>
                   <a:txBody>
                     <a:bodyPr/>
@@ -10370,7 +10370,7 @@
                   </a:tcPr>
                 </a:tc>
               </a:tr>
-              <a:tr h="685800">
+              <a:tr h="548640">
                 <a:tc>
                   <a:txBody>
                     <a:bodyPr/>
@@ -10438,7 +10438,7 @@
                   </a:tcPr>
                 </a:tc>
               </a:tr>
-              <a:tr h="685800">
+              <a:tr h="548640">
                 <a:tc>
                   <a:txBody>
                     <a:bodyPr/>
@@ -10502,6 +10502,74 @@
                   <a:tcPr anchor="ctr">
                     <a:solidFill>
                       <a:srgbClr val="E6F5F2"/>
+                    </a:solidFill>
+                  </a:tcPr>
+                </a:tc>
+              </a:tr>
+              <a:tr h="548640">
+                <a:tc>
+                  <a:txBody>
+                    <a:bodyPr/>
+                    <a:lstStyle/>
+                    <a:p>
+                      <a:r>
+                        <a:rPr sz="900" b="1">
+                          <a:solidFill>
+                            <a:srgbClr val="1F3A5F"/>
+                          </a:solidFill>
+                          <a:latin typeface="Arial"/>
+                        </a:rPr>
+                        <a:t>AC-3</a:t>
+                      </a:r>
+                    </a:p>
+                  </a:txBody>
+                  <a:tcPr anchor="ctr">
+                    <a:solidFill>
+                      <a:srgbClr val="FFFFFF"/>
+                    </a:solidFill>
+                  </a:tcPr>
+                </a:tc>
+                <a:tc>
+                  <a:txBody>
+                    <a:bodyPr/>
+                    <a:lstStyle/>
+                    <a:p>
+                      <a:r>
+                        <a:rPr sz="900">
+                          <a:solidFill>
+                            <a:srgbClr val="1E293B"/>
+                          </a:solidFill>
+                          <a:latin typeface="Arial"/>
+                        </a:rPr>
+                        <a:t>Access Enforcement</a:t>
+                      </a:r>
+                    </a:p>
+                  </a:txBody>
+                  <a:tcPr anchor="ctr">
+                    <a:solidFill>
+                      <a:srgbClr val="FFFFFF"/>
+                    </a:solidFill>
+                  </a:tcPr>
+                </a:tc>
+                <a:tc>
+                  <a:txBody>
+                    <a:bodyPr/>
+                    <a:lstStyle/>
+                    <a:p>
+                      <a:r>
+                        <a:rPr sz="900">
+                          <a:solidFill>
+                            <a:srgbClr val="1E293B"/>
+                          </a:solidFill>
+                          <a:latin typeface="Arial"/>
+                        </a:rPr>
+                        <a:t>Conditional Access exceptions only as governed catalog items with mandatory expiry and scheduled access review</a:t>
+                      </a:r>
+                    </a:p>
+                  </a:txBody>
+                  <a:tcPr anchor="ctr">
+                    <a:solidFill>
+                      <a:srgbClr val="FFFFFF"/>
                     </a:solidFill>
                   </a:tcPr>
                 </a:tc>

</xml_diff>

<commit_message>
build(inbox/aan): regenerate derivatives after the content-correctness burndown (#1217)
Re-rendered the tracked deliverables from the fixed sources:
- 163 figure PNGs re-rasterized from their SVG sources (+ provenance sidecars)
- 12 Vol VII/IX briefing decks (.pptx) regenerated from their specs
- 14 tracked Vol VII/IX book + governance .docx re-rendered via Pandoc
- distribution kit refreshed -> AAN_Federal_Series_Complete_2026-07-15_1503ET.zip

Source content was merged earlier in #1207-#1216; this syncs the binary
derivatives to it. Verified docx carry the fixes.

Co-authored-by: Claude Fable 5 <noreply@anthropic.com>
</commit_message>
<xml_diff>
--- a/inbox/Application Aware Networking/Vol_IX_Book_01_FedAAN_Helpdesk_ITSM_Catalog.pptx
+++ b/inbox/Application Aware Networking/Vol_IX_Book_01_FedAAN_Helpdesk_ITSM_Catalog.pptx
@@ -10234,7 +10234,7 @@
                 <a:gridCol w="2743200"/>
                 <a:gridCol w="2743200"/>
               </a:tblGrid>
-              <a:tr h="685800">
+              <a:tr h="548640">
                 <a:tc>
                   <a:txBody>
                     <a:bodyPr/>
@@ -10302,7 +10302,7 @@
                   </a:tcPr>
                 </a:tc>
               </a:tr>
-              <a:tr h="685800">
+              <a:tr h="548640">
                 <a:tc>
                   <a:txBody>
                     <a:bodyPr/>
@@ -10370,7 +10370,7 @@
                   </a:tcPr>
                 </a:tc>
               </a:tr>
-              <a:tr h="685800">
+              <a:tr h="548640">
                 <a:tc>
                   <a:txBody>
                     <a:bodyPr/>
@@ -10438,7 +10438,7 @@
                   </a:tcPr>
                 </a:tc>
               </a:tr>
-              <a:tr h="685800">
+              <a:tr h="548640">
                 <a:tc>
                   <a:txBody>
                     <a:bodyPr/>
@@ -10502,6 +10502,74 @@
                   <a:tcPr anchor="ctr">
                     <a:solidFill>
                       <a:srgbClr val="E6F5F2"/>
+                    </a:solidFill>
+                  </a:tcPr>
+                </a:tc>
+              </a:tr>
+              <a:tr h="548640">
+                <a:tc>
+                  <a:txBody>
+                    <a:bodyPr/>
+                    <a:lstStyle/>
+                    <a:p>
+                      <a:r>
+                        <a:rPr sz="900" b="1">
+                          <a:solidFill>
+                            <a:srgbClr val="1F3A5F"/>
+                          </a:solidFill>
+                          <a:latin typeface="Arial"/>
+                        </a:rPr>
+                        <a:t>AC-3</a:t>
+                      </a:r>
+                    </a:p>
+                  </a:txBody>
+                  <a:tcPr anchor="ctr">
+                    <a:solidFill>
+                      <a:srgbClr val="FFFFFF"/>
+                    </a:solidFill>
+                  </a:tcPr>
+                </a:tc>
+                <a:tc>
+                  <a:txBody>
+                    <a:bodyPr/>
+                    <a:lstStyle/>
+                    <a:p>
+                      <a:r>
+                        <a:rPr sz="900">
+                          <a:solidFill>
+                            <a:srgbClr val="1E293B"/>
+                          </a:solidFill>
+                          <a:latin typeface="Arial"/>
+                        </a:rPr>
+                        <a:t>Access Enforcement</a:t>
+                      </a:r>
+                    </a:p>
+                  </a:txBody>
+                  <a:tcPr anchor="ctr">
+                    <a:solidFill>
+                      <a:srgbClr val="FFFFFF"/>
+                    </a:solidFill>
+                  </a:tcPr>
+                </a:tc>
+                <a:tc>
+                  <a:txBody>
+                    <a:bodyPr/>
+                    <a:lstStyle/>
+                    <a:p>
+                      <a:r>
+                        <a:rPr sz="900">
+                          <a:solidFill>
+                            <a:srgbClr val="1E293B"/>
+                          </a:solidFill>
+                          <a:latin typeface="Arial"/>
+                        </a:rPr>
+                        <a:t>Conditional Access exceptions only as governed catalog items with mandatory expiry and scheduled access review</a:t>
+                      </a:r>
+                    </a:p>
+                  </a:txBody>
+                  <a:tcPr anchor="ctr">
+                    <a:solidFill>
+                      <a:srgbClr val="FFFFFF"/>
                     </a:solidFill>
                   </a:tcPr>
                 </a:tc>

</xml_diff>